<commit_message>
feat: rebuild the three books with carpentry and BCBC content, and point the Intake 142 decks at the new pages
- Textbook 368 pages, Exercise Book 141, Answer Key 52. Every Example, Figure, Table, set and question keeps its number.
- Carpentry sections and a "Carpentry and the BCBC" set in every chapter, with code values checked against the code text
  and the table pages corrected (Table 9.8.4.1 on 9-31, Table 9.26.3.1 on 9-242).
- Appendix A Kitchen math and Appendix B Practice Assessment. Web editions of all three books.
- Book source can rebuild the books from this repo: plates read from bcbc/, and only the 29 cited Articles are kept.
- All 26 Intake 142 decks: book page references and links moved to the new pages, and tool wording matches the hub.
</commit_message>
<xml_diff>
--- a/carpentry/intake-142/PowerPoint/Day-01_2026-10-29_Week-1.pptx
+++ b/carpentry/intake-142/PowerPoint/Day-01_2026-10-29_Week-1.pptx
@@ -1097,7 +1097,7 @@
           <a:p/>
           <a:p>
             <a:r>
-              <a:t>On page 12, trace the four pieces in Figure 1.2: 1,250 mm, 875 mm, 640 mm and 1,480 mm. The question mark represents their combined length. Before calculating, point to every piece that must be included. Which operation combines these four lengths? Addition, because each contributes to the total. Notice that all four dimensions use millimetres; we can add them directly. A drawing helps us check that no piece has been omitted or counted twice. Read the labels rather than measuring the projected picture, whose size changes with the screen.</a:t>
+              <a:t>On page 14, trace the four pieces in Figure 1.2: 1,250 mm, 875 mm, 640 mm and 1,480 mm. The question mark represents their combined length. Before calculating, point to every piece that must be included. Which operation combines these four lengths? Addition, because each contributes to the total. Notice that all four dimensions use millimetres; we can add them directly. A drawing helps us check that no piece has been omitted or counted twice. Read the labels rather than measuring the projected picture, whose size changes with the screen.</a:t>
             </a:r>
           </a:p>
         </p:txBody>
@@ -2683,7 +2683,7 @@
           <a:p/>
           <a:p>
             <a:r>
-              <a:t>The textbook's table on page 29 compares the two calculators. On the TI-30Xa, enter the number before the square-root key; on the Sharp, press the root key first, enter the number and finish with equals. For change sign, the TI sequence places the sign key after the digits, while the Sharp sequence places it before. Which row should you follow today? The row for the model you are actually holding. Locate your correction key as well: the TI uses the left-arrow key, and the Sharp uses DEL.</a:t>
+              <a:t>The textbook's table on page 49 compares the two calculators. On the TI-30Xa, enter the number before the square-root key; on the Sharp, press the root key first, enter the number and finish with equals. For change sign, the TI sequence places the sign key after the digits, while the Sharp sequence places it before. Which row should you follow today? The row for the model you are actually holding. Locate your correction key as well: the TI uses the left-arrow key, and the Sharp uses DEL.</a:t>
             </a:r>
           </a:p>
         </p:txBody>
@@ -2759,7 +2759,7 @@
           <a:p/>
           <a:p>
             <a:r>
-              <a:t>Page 32 demonstrates 12 squared and the square root of 144. Twelve times twelve makes 144; the root reverses that relationship to give 12. On the TI, 12 then x² gives the square, and 144 then √x gives the root. The Sharp uses 12, x², equals, or √, 144, equals. What stays the same between the two models? The mathematical relationship and the correct result. What changes? The order of the keys needed to express that relationship. Read the intended expression before using either sequence.</a:t>
+              <a:t>Page 52 demonstrates 12 squared and the square root of 144. Twelve times twelve makes 144; the root reverses that relationship to give 12. On the TI, 12 then x² gives the square, and 144 then √x gives the root. The Sharp uses 12, x², equals, or √, 144, equals. What stays the same between the two models? The mathematical relationship and the correct result. What changes? The order of the keys needed to express that relationship. Read the intended expression before using either sequence.</a:t>
             </a:r>
           </a:p>
         </p:txBody>
@@ -5557,7 +5557,7 @@
                 </a:solidFill>
                 <a:latin typeface="Arial"/>
               </a:rPr>
-              <a:t>Textbook  |  page 12</a:t>
+              <a:t>Textbook  |  page 14</a:t>
             </a:r>
           </a:p>
         </p:txBody>
@@ -5605,7 +5605,7 @@
                 </a:solidFill>
                 <a:latin typeface="Arial"/>
               </a:rPr>
-              <a:t>Textbook Chapter 1 pp.10–21; Chapter 2 pp.28–31,39</a:t>
+              <a:t>Textbook Chapter 1 pp.12–23; Chapter 2 pp.48–51,59</a:t>
             </a:r>
           </a:p>
         </p:txBody>
@@ -5677,7 +5677,7 @@
                 </a:solidFill>
                 <a:latin typeface="Arial"/>
               </a:rPr>
-              <a:t>Textbook p.12 · Example 1.4: estimate before calculating.</a:t>
+              <a:t>Textbook p.14 · Example 1.4: estimate before calculating.</a:t>
             </a:r>
           </a:p>
         </p:txBody>
@@ -6291,7 +6291,7 @@
                 </a:solidFill>
                 <a:latin typeface="Arial"/>
               </a:rPr>
-              <a:t>Textbook Chapter 1 pp.10–21; Chapter 2 pp.28–31,39</a:t>
+              <a:t>Textbook Chapter 1 pp.12–23; Chapter 2 pp.48–51,59</a:t>
             </a:r>
           </a:p>
         </p:txBody>
@@ -7049,7 +7049,7 @@
                 </a:solidFill>
                 <a:latin typeface="Arial"/>
               </a:rPr>
-              <a:t>Textbook Chapter 1 pp.10–21; Chapter 2 pp.28–31,39</a:t>
+              <a:t>Textbook Chapter 1 pp.12–23; Chapter 2 pp.48–51,59</a:t>
             </a:r>
           </a:p>
         </p:txBody>
@@ -7863,7 +7863,7 @@
                 </a:solidFill>
                 <a:latin typeface="Arial"/>
               </a:rPr>
-              <a:t>Textbook Chapter 1 pp.10–21; Chapter 2 pp.28–31,39</a:t>
+              <a:t>Textbook Chapter 1 pp.12–23; Chapter 2 pp.48–51,59</a:t>
             </a:r>
           </a:p>
         </p:txBody>
@@ -8619,7 +8619,7 @@
                 </a:solidFill>
                 <a:latin typeface="Arial"/>
               </a:rPr>
-              <a:t>Textbook Chapter 1 pp.10–21; Chapter 2 pp.28–31,39</a:t>
+              <a:t>Textbook Chapter 1 pp.12–23; Chapter 2 pp.48–51,59</a:t>
             </a:r>
           </a:p>
         </p:txBody>
@@ -9353,7 +9353,7 @@
                 </a:solidFill>
                 <a:latin typeface="Arial"/>
               </a:rPr>
-              <a:t>Textbook Chapter 1 pp.10–21; Chapter 2 pp.28–31,39</a:t>
+              <a:t>Textbook Chapter 1 pp.12–23; Chapter 2 pp.48–51,59</a:t>
             </a:r>
           </a:p>
         </p:txBody>
@@ -9401,7 +9401,7 @@
                 </a:solidFill>
                 <a:latin typeface="Arial"/>
               </a:rPr>
-              <a:t>Complete Exercise Book 1A Q1–10 and Q12,14,16,17 as time allows. On Shape Canvas, set a rectangle to 1,200 mm by 800 mm and read both sizes; geometry is preview only.</a:t>
+              <a:t>Complete Exercise Book 1A Q1–10 and Q12,14,16,17 as time allows. On Shape Canvas, set a rectangle to 1,200 mm by 800 mm and read both sizes only, since area and perimeter come later in the course.</a:t>
             </a:r>
           </a:p>
         </p:txBody>
@@ -10167,7 +10167,7 @@
                 </a:solidFill>
                 <a:latin typeface="Arial"/>
               </a:rPr>
-              <a:t>Textbook Chapter 1 pp.10–21; Chapter 2 pp.28–31,39</a:t>
+              <a:t>Textbook Chapter 1 pp.12–23; Chapter 2 pp.48–51,59</a:t>
             </a:r>
           </a:p>
         </p:txBody>
@@ -10943,7 +10943,7 @@
                 </a:solidFill>
                 <a:latin typeface="Arial"/>
               </a:rPr>
-              <a:t>Textbook Chapter 1 pp.10–21; Chapter 2 pp.28–31,39</a:t>
+              <a:t>Textbook Chapter 1 pp.12–23; Chapter 2 pp.48–51,59</a:t>
             </a:r>
           </a:p>
         </p:txBody>
@@ -11902,7 +11902,7 @@
                 </a:solidFill>
                 <a:latin typeface="Arial"/>
               </a:rPr>
-              <a:t>Textbook Chapter 1 pp.10–21; Chapter 2 pp.28–31,39</a:t>
+              <a:t>Textbook Chapter 1 pp.12–23; Chapter 2 pp.48–51,59</a:t>
             </a:r>
           </a:p>
         </p:txBody>
@@ -12613,7 +12613,7 @@
                 </a:solidFill>
                 <a:latin typeface="Arial"/>
               </a:rPr>
-              <a:t>Textbook Chapter 1 pp.10–21; Chapter 2 pp.28–31,39</a:t>
+              <a:t>Textbook Chapter 1 pp.12–23; Chapter 2 pp.48–51,59</a:t>
             </a:r>
           </a:p>
         </p:txBody>
@@ -16676,7 +16676,7 @@
                 </a:solidFill>
                 <a:latin typeface="Arial"/>
               </a:rPr>
-              <a:t>Textbook Chapter 1 pp.10–21; Chapter 2 pp.28–31,39</a:t>
+              <a:t>Textbook Chapter 1 pp.12–23; Chapter 2 pp.48–51,59</a:t>
             </a:r>
           </a:p>
         </p:txBody>
@@ -17490,7 +17490,7 @@
                 </a:solidFill>
                 <a:latin typeface="Arial"/>
               </a:rPr>
-              <a:t>Textbook Chapter 1 pp.10–21; Chapter 2 pp.28–31,39</a:t>
+              <a:t>Textbook Chapter 1 pp.12–23; Chapter 2 pp.48–51,59</a:t>
             </a:r>
           </a:p>
         </p:txBody>
@@ -18201,7 +18201,7 @@
                 </a:solidFill>
                 <a:latin typeface="Arial"/>
               </a:rPr>
-              <a:t>Textbook Chapter 1 pp.10–21; Chapter 2 pp.28–31,39</a:t>
+              <a:t>Textbook Chapter 1 pp.12–23; Chapter 2 pp.48–51,59</a:t>
             </a:r>
           </a:p>
         </p:txBody>
@@ -18912,7 +18912,7 @@
                 </a:solidFill>
                 <a:latin typeface="Arial"/>
               </a:rPr>
-              <a:t>Textbook Chapter 1 pp.10–21; Chapter 2 pp.28–31,39</a:t>
+              <a:t>Textbook Chapter 1 pp.12–23; Chapter 2 pp.48–51,59</a:t>
             </a:r>
           </a:p>
         </p:txBody>
@@ -20391,7 +20391,7 @@
                 </a:solidFill>
                 <a:latin typeface="Arial"/>
               </a:rPr>
-              <a:t>Textbook Chapter 2 pp.28–33,39; Chapter 1 pp.12–21</a:t>
+              <a:t>Textbook Chapter 2 pp.48–53,59; Chapter 1 pp.14–23</a:t>
             </a:r>
           </a:p>
         </p:txBody>
@@ -20591,7 +20591,7 @@
                 </a:solidFill>
                 <a:latin typeface="Arial"/>
               </a:rPr>
-              <a:t>Textbook Chapter 2 pp.28–33,39; Chapter 1 pp.12–21</a:t>
+              <a:t>Textbook Chapter 2 pp.48–53,59; Chapter 1 pp.14–23</a:t>
             </a:r>
           </a:p>
         </p:txBody>
@@ -20639,7 +20639,7 @@
                 </a:solidFill>
                 <a:latin typeface="Arial"/>
               </a:rPr>
-              <a:t>Exercise Book 2A Q1–3,6 (p.13); 1A Q11–17,20 (pp.6–7)</a:t>
+              <a:t>Exercise Book 2A Q1–3,6 (p.17); 1A Q11–17,20 (pp.6–7)</a:t>
             </a:r>
           </a:p>
         </p:txBody>
@@ -21301,7 +21301,7 @@
                 </a:solidFill>
                 <a:latin typeface="Arial"/>
               </a:rPr>
-              <a:t>Textbook Chapter 2 pp.28–33,39; Chapter 1 pp.12–21</a:t>
+              <a:t>Textbook Chapter 2 pp.48–53,59; Chapter 1 pp.14–23</a:t>
             </a:r>
           </a:p>
         </p:txBody>
@@ -21501,7 +21501,7 @@
                 </a:solidFill>
                 <a:latin typeface="Arial"/>
               </a:rPr>
-              <a:t>Resources: Exercise Book 2A Q1–3,6 (p.13); 1A Q11–17,20 (pp.6–7)</a:t>
+              <a:t>Resources: Exercise Book 2A Q1–3,6 (p.17); 1A Q11–17,20 (pp.6–7)</a:t>
             </a:r>
           </a:p>
         </p:txBody>
@@ -22250,7 +22250,7 @@
                 </a:solidFill>
                 <a:latin typeface="Arial"/>
               </a:rPr>
-              <a:t>Textbook Chapter 2 pp.28–33,39; Chapter 1 pp.12–21</a:t>
+              <a:t>Textbook Chapter 2 pp.48–53,59; Chapter 1 pp.14–23</a:t>
             </a:r>
           </a:p>
         </p:txBody>
@@ -23471,7 +23471,7 @@
                 </a:solidFill>
                 <a:latin typeface="Arial"/>
               </a:rPr>
-              <a:t>Textbook Chapter 2 pp.28–33,39; Chapter 1 pp.12–21</a:t>
+              <a:t>Textbook Chapter 2 pp.48–53,59; Chapter 1 pp.14–23</a:t>
             </a:r>
           </a:p>
         </p:txBody>
@@ -24792,7 +24792,7 @@
                 <a:ea typeface="Arial" pitchFamily="34" charset="-122"/>
                 <a:cs typeface="Arial" pitchFamily="34" charset="-120"/>
               </a:rPr>
-              <a:t>Exercise Book 2A Q1–3, p.13. Record calculation, keys and answer; compare root entry on the two models.</a:t>
+              <a:t>Exercise Book 2A Q1–3, p.17. Record calculation, keys and answer; compare root entry on the two models.</a:t>
             </a:r>
             <a:endParaRPr lang="en-US" sz="1800" dirty="0"/>
           </a:p>
@@ -25445,7 +25445,7 @@
                 </a:solidFill>
                 <a:latin typeface="Arial"/>
               </a:rPr>
-              <a:t>Textbook Chapter 1 pp.10–21; Chapter 2 pp.28–31,39</a:t>
+              <a:t>Textbook Chapter 1 pp.12–23; Chapter 2 pp.48–51,59</a:t>
             </a:r>
           </a:p>
         </p:txBody>
@@ -25645,7 +25645,7 @@
                 </a:solidFill>
                 <a:latin typeface="Arial"/>
               </a:rPr>
-              <a:t>Textbook Chapter 1 pp.10–21; Chapter 2 pp.28–31,39</a:t>
+              <a:t>Textbook Chapter 1 pp.12–23; Chapter 2 pp.48–51,59</a:t>
             </a:r>
           </a:p>
         </p:txBody>
@@ -26307,7 +26307,7 @@
                 </a:solidFill>
                 <a:latin typeface="Arial"/>
               </a:rPr>
-              <a:t>Textbook  |  page 29</a:t>
+              <a:t>Textbook  |  page 49</a:t>
             </a:r>
           </a:p>
         </p:txBody>
@@ -26355,7 +26355,7 @@
                 </a:solidFill>
                 <a:latin typeface="Arial"/>
               </a:rPr>
-              <a:t>Textbook Chapter 2 pp.28–33,39; Chapter 1 pp.12–21</a:t>
+              <a:t>Textbook Chapter 2 pp.48–53,59; Chapter 1 pp.14–23</a:t>
             </a:r>
           </a:p>
         </p:txBody>
@@ -26427,7 +26427,7 @@
                 </a:solidFill>
                 <a:latin typeface="Arial"/>
               </a:rPr>
-              <a:t>Textbook p.29 · Table 2.1: key differences between the two calculators.</a:t>
+              <a:t>Textbook p.49 · Table 2.1: key differences between the two calculators.</a:t>
             </a:r>
           </a:p>
         </p:txBody>
@@ -26993,7 +26993,7 @@
                 </a:solidFill>
                 <a:latin typeface="Arial"/>
               </a:rPr>
-              <a:t>Textbook  |  page 32</a:t>
+              <a:t>Textbook  |  page 52</a:t>
             </a:r>
           </a:p>
         </p:txBody>
@@ -27041,7 +27041,7 @@
                 </a:solidFill>
                 <a:latin typeface="Arial"/>
               </a:rPr>
-              <a:t>Textbook Chapter 2 pp.28–33,39; Chapter 1 pp.12–21</a:t>
+              <a:t>Textbook Chapter 2 pp.48–53,59; Chapter 1 pp.14–23</a:t>
             </a:r>
           </a:p>
         </p:txBody>
@@ -27113,7 +27113,7 @@
                 </a:solidFill>
                 <a:latin typeface="Arial"/>
               </a:rPr>
-              <a:t>Textbook p.32 · Square and square-root key sequences; each checks the other.</a:t>
+              <a:t>Textbook p.52 · Square and square-root key sequences; each checks the other.</a:t>
             </a:r>
           </a:p>
         </p:txBody>
@@ -27727,7 +27727,7 @@
                 </a:solidFill>
                 <a:latin typeface="Arial"/>
               </a:rPr>
-              <a:t>Textbook Chapter 2 pp.28–33,39; Chapter 1 pp.12–21</a:t>
+              <a:t>Textbook Chapter 2 pp.48–53,59; Chapter 1 pp.14–23</a:t>
             </a:r>
           </a:p>
         </p:txBody>
@@ -28485,7 +28485,7 @@
                 </a:solidFill>
                 <a:latin typeface="Arial"/>
               </a:rPr>
-              <a:t>Textbook Chapter 2 pp.28–33,39; Chapter 1 pp.12–21</a:t>
+              <a:t>Textbook Chapter 2 pp.48–53,59; Chapter 1 pp.14–23</a:t>
             </a:r>
           </a:p>
         </p:txBody>
@@ -28685,7 +28685,7 @@
                 </a:solidFill>
                 <a:latin typeface="Arial"/>
               </a:rPr>
-              <a:t>Resources: Exercise Book 2A Q1–3,6 (p.13); 1A Q11–17,20 (pp.6–7)</a:t>
+              <a:t>Resources: Exercise Book 2A Q1–3,6 (p.17); 1A Q11–17,20 (pp.6–7)</a:t>
             </a:r>
           </a:p>
         </p:txBody>
@@ -29299,7 +29299,7 @@
                 </a:solidFill>
                 <a:latin typeface="Arial"/>
               </a:rPr>
-              <a:t>Textbook Chapter 2 pp.28–33,39; Chapter 1 pp.12–21</a:t>
+              <a:t>Textbook Chapter 2 pp.48–53,59; Chapter 1 pp.14–23</a:t>
             </a:r>
           </a:p>
         </p:txBody>
@@ -30055,7 +30055,7 @@
                 </a:solidFill>
                 <a:latin typeface="Arial"/>
               </a:rPr>
-              <a:t>Textbook Chapter 2 pp.28–33,39; Chapter 1 pp.12–21</a:t>
+              <a:t>Textbook Chapter 2 pp.48–53,59; Chapter 1 pp.14–23</a:t>
             </a:r>
           </a:p>
         </p:txBody>
@@ -30789,7 +30789,7 @@
                 </a:solidFill>
                 <a:latin typeface="Arial"/>
               </a:rPr>
-              <a:t>Textbook Chapter 2 pp.28–33,39; Chapter 1 pp.12–21</a:t>
+              <a:t>Textbook Chapter 2 pp.48–53,59; Chapter 1 pp.14–23</a:t>
             </a:r>
           </a:p>
         </p:txBody>
@@ -30989,7 +30989,7 @@
                 </a:solidFill>
                 <a:latin typeface="Arial"/>
               </a:rPr>
-              <a:t>Resources: Exercise Book 2A Q1–3,6 (p.13); 1A Q11–17,20 (pp.6–7)</a:t>
+              <a:t>Resources: Exercise Book 2A Q1–3,6 (p.17); 1A Q11–17,20 (pp.6–7)</a:t>
             </a:r>
           </a:p>
         </p:txBody>
@@ -31603,7 +31603,7 @@
                 </a:solidFill>
                 <a:latin typeface="Arial"/>
               </a:rPr>
-              <a:t>Textbook Chapter 2 pp.28–33,39; Chapter 1 pp.12–21</a:t>
+              <a:t>Textbook Chapter 2 pp.48–53,59; Chapter 1 pp.14–23</a:t>
             </a:r>
           </a:p>
         </p:txBody>
@@ -32379,7 +32379,7 @@
                 </a:solidFill>
                 <a:latin typeface="Arial"/>
               </a:rPr>
-              <a:t>Textbook Chapter 2 pp.28–33,39; Chapter 1 pp.12–21</a:t>
+              <a:t>Textbook Chapter 2 pp.48–53,59; Chapter 1 pp.14–23</a:t>
             </a:r>
           </a:p>
         </p:txBody>
@@ -33338,7 +33338,7 @@
                 </a:solidFill>
                 <a:latin typeface="Arial"/>
               </a:rPr>
-              <a:t>Textbook Chapter 2 pp.28–33,39; Chapter 1 pp.12–21</a:t>
+              <a:t>Textbook Chapter 2 pp.48–53,59; Chapter 1 pp.14–23</a:t>
             </a:r>
           </a:p>
         </p:txBody>
@@ -34049,7 +34049,7 @@
                 </a:solidFill>
                 <a:latin typeface="Arial"/>
               </a:rPr>
-              <a:t>Textbook Chapter 1 pp.10–21; Chapter 2 pp.28–31,39</a:t>
+              <a:t>Textbook Chapter 1 pp.12–23; Chapter 2 pp.48–51,59</a:t>
             </a:r>
           </a:p>
         </p:txBody>
@@ -34863,7 +34863,7 @@
                 </a:solidFill>
                 <a:latin typeface="Arial"/>
               </a:rPr>
-              <a:t>Textbook Chapter 2 pp.28–33,39; Chapter 1 pp.12–21</a:t>
+              <a:t>Textbook Chapter 2 pp.48–53,59; Chapter 1 pp.14–23</a:t>
             </a:r>
           </a:p>
         </p:txBody>
@@ -35574,7 +35574,7 @@
                 </a:solidFill>
                 <a:latin typeface="Arial"/>
               </a:rPr>
-              <a:t>Textbook Chapter 2 pp.28–33,39; Chapter 1 pp.12–21</a:t>
+              <a:t>Textbook Chapter 2 pp.48–53,59; Chapter 1 pp.14–23</a:t>
             </a:r>
           </a:p>
         </p:txBody>
@@ -35774,7 +35774,7 @@
                 </a:solidFill>
                 <a:latin typeface="Arial"/>
               </a:rPr>
-              <a:t>Resources: Exercise Book 2A Q1–3,6 (p.13); 1A Q11–17,20 (pp.6–7)</a:t>
+              <a:t>Resources: Exercise Book 2A Q1–3,6 (p.17); 1A Q11–17,20 (pp.6–7)</a:t>
             </a:r>
           </a:p>
         </p:txBody>
@@ -36388,7 +36388,7 @@
                 </a:solidFill>
                 <a:latin typeface="Arial"/>
               </a:rPr>
-              <a:t>Textbook Chapter 2 pp.28–33,39; Chapter 1 pp.12–21</a:t>
+              <a:t>Textbook Chapter 2 pp.48–53,59; Chapter 1 pp.14–23</a:t>
             </a:r>
           </a:p>
         </p:txBody>
@@ -37099,7 +37099,7 @@
                 </a:solidFill>
                 <a:latin typeface="Arial"/>
               </a:rPr>
-              <a:t>Textbook Chapter 2 pp.28–33,39; Chapter 1 pp.12–21</a:t>
+              <a:t>Textbook Chapter 2 pp.48–53,59; Chapter 1 pp.14–23</a:t>
             </a:r>
           </a:p>
         </p:txBody>
@@ -37810,7 +37810,7 @@
                 </a:solidFill>
                 <a:latin typeface="Arial"/>
               </a:rPr>
-              <a:t>Textbook Chapter 2 pp.28–33,39; Chapter 1 pp.12–21</a:t>
+              <a:t>Textbook Chapter 2 pp.48–53,59; Chapter 1 pp.14–23</a:t>
             </a:r>
           </a:p>
         </p:txBody>
@@ -38010,7 +38010,7 @@
                 </a:solidFill>
                 <a:latin typeface="Arial"/>
               </a:rPr>
-              <a:t>Resources: Exercise Book 2A Q1–3,6 (p.13); 1A Q11–17,20 (pp.6–7)</a:t>
+              <a:t>Resources: Exercise Book 2A Q1–3,6 (p.17); 1A Q11–17,20 (pp.6–7)</a:t>
             </a:r>
           </a:p>
         </p:txBody>
@@ -38624,7 +38624,7 @@
                 </a:solidFill>
                 <a:latin typeface="Arial"/>
               </a:rPr>
-              <a:t>Textbook Chapter 1 pp.10–21; Chapter 2 pp.28–31,39</a:t>
+              <a:t>Textbook Chapter 1 pp.12–23; Chapter 2 pp.48–51,59</a:t>
             </a:r>
           </a:p>
         </p:txBody>
@@ -39470,7 +39470,7 @@
                 </a:solidFill>
                 <a:latin typeface="Arial"/>
               </a:rPr>
-              <a:t>Textbook Chapter 1 pp.10–21; Chapter 2 pp.28–31,39</a:t>
+              <a:t>Textbook Chapter 1 pp.12–23; Chapter 2 pp.48–51,59</a:t>
             </a:r>
           </a:p>
         </p:txBody>
@@ -40715,7 +40715,7 @@
                 </a:solidFill>
                 <a:latin typeface="Arial"/>
               </a:rPr>
-              <a:t>Textbook Chapter 1 pp.10–21; Chapter 2 pp.28–31,39</a:t>
+              <a:t>Textbook Chapter 1 pp.12–23; Chapter 2 pp.48–51,59</a:t>
             </a:r>
           </a:p>
         </p:txBody>
@@ -42690,7 +42690,7 @@
                 </a:solidFill>
                 <a:latin typeface="Arial"/>
               </a:rPr>
-              <a:t>Textbook  |  page 12</a:t>
+              <a:t>Textbook  |  page 14</a:t>
             </a:r>
           </a:p>
         </p:txBody>
@@ -42738,7 +42738,7 @@
                 </a:solidFill>
                 <a:latin typeface="Arial"/>
               </a:rPr>
-              <a:t>Textbook Chapter 1 pp.10–21; Chapter 2 pp.28–31,39</a:t>
+              <a:t>Textbook Chapter 1 pp.12–23; Chapter 2 pp.48–51,59</a:t>
             </a:r>
           </a:p>
         </p:txBody>
@@ -42810,7 +42810,7 @@
                 </a:solidFill>
                 <a:latin typeface="Arial"/>
               </a:rPr>
-              <a:t>Textbook p.12 · Figure 1.2: read the cut-list dimensions.</a:t>
+              <a:t>Textbook p.14 · Figure 1.2: read the cut-list dimensions.</a:t>
             </a:r>
           </a:p>
         </p:txBody>

</xml_diff>

<commit_message>
Add lecture quiz game, fillable quizzes and slide links
</commit_message>
<xml_diff>
--- a/carpentry/intake-142/PowerPoint/Day-01_2026-10-29_Week-1.pptx
+++ b/carpentry/intake-142/PowerPoint/Day-01_2026-10-29_Week-1.pptx
@@ -19385,6 +19385,104 @@
           </a:p>
         </p:txBody>
       </p:sp>
+      <p:sp>
+        <p:nvSpPr>
+          <p:cNvPr id="22" name="Play quiz W01-L01"/>
+          <p:cNvSpPr txBox="1"/>
+          <p:nvPr/>
+        </p:nvSpPr>
+        <p:spPr>
+          <a:xfrm>
+            <a:off x="6355080" y="6606540"/>
+            <a:ext cx="822960" cy="210312"/>
+          </a:xfrm>
+          <a:prstGeom prst="rect">
+            <a:avLst/>
+          </a:prstGeom>
+          <a:noFill/>
+        </p:spPr>
+        <p:txBody>
+          <a:bodyPr wrap="square" lIns="0" rIns="0" tIns="0" bIns="0" anchor="t">
+            <a:normAutofit fontScale="100000" lnSpcReduction="0"/>
+          </a:bodyPr>
+          <a:lstStyle/>
+          <a:p>
+            <a:pPr>
+              <a:spcBef>
+                <a:spcPts val="0"/>
+              </a:spcBef>
+              <a:spcAft>
+                <a:spcPts val="0"/>
+              </a:spcAft>
+              <a:defRPr sz="1000" b="0">
+                <a:solidFill>
+                  <a:srgbClr val="D0002B"/>
+                </a:solidFill>
+                <a:latin typeface="Arial"/>
+              </a:defRPr>
+            </a:pPr>
+            <a:r>
+              <a:rPr sz="1000">
+                <a:solidFill>
+                  <a:srgbClr val="F7F8FC"/>
+                </a:solidFill>
+                <a:latin typeface="Arial"/>
+                <a:hlinkClick r:id="rId8"/>
+              </a:rPr>
+              <a:t>Play quiz</a:t>
+            </a:r>
+          </a:p>
+        </p:txBody>
+      </p:sp>
+      <p:sp>
+        <p:nvSpPr>
+          <p:cNvPr id="23" name="Quiz PDF W01-L01"/>
+          <p:cNvSpPr txBox="1"/>
+          <p:nvPr/>
+        </p:nvSpPr>
+        <p:spPr>
+          <a:xfrm>
+            <a:off x="7296912" y="6606540"/>
+            <a:ext cx="1005840" cy="210312"/>
+          </a:xfrm>
+          <a:prstGeom prst="rect">
+            <a:avLst/>
+          </a:prstGeom>
+          <a:noFill/>
+        </p:spPr>
+        <p:txBody>
+          <a:bodyPr wrap="square" lIns="0" rIns="0" tIns="0" bIns="0" anchor="t">
+            <a:normAutofit fontScale="100000" lnSpcReduction="0"/>
+          </a:bodyPr>
+          <a:lstStyle/>
+          <a:p>
+            <a:pPr>
+              <a:spcBef>
+                <a:spcPts val="0"/>
+              </a:spcBef>
+              <a:spcAft>
+                <a:spcPts val="0"/>
+              </a:spcAft>
+              <a:defRPr sz="1000" b="0">
+                <a:solidFill>
+                  <a:srgbClr val="D0002B"/>
+                </a:solidFill>
+                <a:latin typeface="Arial"/>
+              </a:defRPr>
+            </a:pPr>
+            <a:r>
+              <a:rPr sz="1000">
+                <a:solidFill>
+                  <a:srgbClr val="F7F8FC"/>
+                </a:solidFill>
+                <a:latin typeface="Arial"/>
+                <a:hlinkClick r:id="rId9"/>
+              </a:rPr>
+              <a:t>Quiz PDF</a:t>
+            </a:r>
+          </a:p>
+        </p:txBody>
+      </p:sp>
     </p:spTree>
   </p:cSld>
   <p:clrMapOvr>
@@ -38279,6 +38377,104 @@
                 <a:latin typeface="Arial"/>
               </a:rPr>
               <a:t>Day 01  •  2026-10-29  •  44</a:t>
+            </a:r>
+          </a:p>
+        </p:txBody>
+      </p:sp>
+      <p:sp>
+        <p:nvSpPr>
+          <p:cNvPr id="22" name="Play quiz W01-L02"/>
+          <p:cNvSpPr txBox="1"/>
+          <p:nvPr/>
+        </p:nvSpPr>
+        <p:spPr>
+          <a:xfrm>
+            <a:off x="6355080" y="6606540"/>
+            <a:ext cx="822960" cy="210312"/>
+          </a:xfrm>
+          <a:prstGeom prst="rect">
+            <a:avLst/>
+          </a:prstGeom>
+          <a:noFill/>
+        </p:spPr>
+        <p:txBody>
+          <a:bodyPr wrap="square" lIns="0" rIns="0" tIns="0" bIns="0" anchor="t">
+            <a:normAutofit fontScale="100000" lnSpcReduction="0"/>
+          </a:bodyPr>
+          <a:lstStyle/>
+          <a:p>
+            <a:pPr>
+              <a:spcBef>
+                <a:spcPts val="0"/>
+              </a:spcBef>
+              <a:spcAft>
+                <a:spcPts val="0"/>
+              </a:spcAft>
+              <a:defRPr sz="1000" b="0">
+                <a:solidFill>
+                  <a:srgbClr val="D0002B"/>
+                </a:solidFill>
+                <a:latin typeface="Arial"/>
+              </a:defRPr>
+            </a:pPr>
+            <a:r>
+              <a:rPr sz="1000">
+                <a:solidFill>
+                  <a:srgbClr val="F7F8FC"/>
+                </a:solidFill>
+                <a:latin typeface="Arial"/>
+                <a:hlinkClick r:id="rId8"/>
+              </a:rPr>
+              <a:t>Play quiz</a:t>
+            </a:r>
+          </a:p>
+        </p:txBody>
+      </p:sp>
+      <p:sp>
+        <p:nvSpPr>
+          <p:cNvPr id="23" name="Quiz PDF W01-L02"/>
+          <p:cNvSpPr txBox="1"/>
+          <p:nvPr/>
+        </p:nvSpPr>
+        <p:spPr>
+          <a:xfrm>
+            <a:off x="7296912" y="6606540"/>
+            <a:ext cx="1005840" cy="210312"/>
+          </a:xfrm>
+          <a:prstGeom prst="rect">
+            <a:avLst/>
+          </a:prstGeom>
+          <a:noFill/>
+        </p:spPr>
+        <p:txBody>
+          <a:bodyPr wrap="square" lIns="0" rIns="0" tIns="0" bIns="0" anchor="t">
+            <a:normAutofit fontScale="100000" lnSpcReduction="0"/>
+          </a:bodyPr>
+          <a:lstStyle/>
+          <a:p>
+            <a:pPr>
+              <a:spcBef>
+                <a:spcPts val="0"/>
+              </a:spcBef>
+              <a:spcAft>
+                <a:spcPts val="0"/>
+              </a:spcAft>
+              <a:defRPr sz="1000" b="0">
+                <a:solidFill>
+                  <a:srgbClr val="D0002B"/>
+                </a:solidFill>
+                <a:latin typeface="Arial"/>
+              </a:defRPr>
+            </a:pPr>
+            <a:r>
+              <a:rPr sz="1000">
+                <a:solidFill>
+                  <a:srgbClr val="F7F8FC"/>
+                </a:solidFill>
+                <a:latin typeface="Arial"/>
+                <a:hlinkClick r:id="rId9"/>
+              </a:rPr>
+              <a:t>Quiz PDF</a:t>
             </a:r>
           </a:p>
         </p:txBody>

</xml_diff>